<commit_message>
Static decks: rewrite teacher notes for final state; consistent Cl- label (U2 S2.3, S2.4)
Co-Authored-By: Claude Sonnet 5.5 <noreply@anthropic.com>
Claude-Session: https://claude.ai/code/session_01CAqidLLu6PiYNMcZx5qMsE
</commit_message>
<xml_diff>
--- a/deliverables/chem-u02/SHULL_CHEM_Slides_U02_S02.3_Static.pptx
+++ b/deliverables/chem-u02/SHULL_CHEM_Slides_U02_S02.3_Static.pptx
@@ -708,7 +708,12 @@
           </a:p>
           <a:p>
             <a:r>
-              <a:t>STATIC FINAL STATE: print and handout copy, no animation. This slide shows the final state of the click build; the animated deck shows it one click at a time.</a:t>
+              <a:t>STATIC FINAL STATE: print and handout copy, no animation. This slide shows the final state of the build.</a:t>
+            </a:r>
+          </a:p>
+          <a:p>
+            <a:r>
+              <a:t>Animated version: SHULL_CHEM_Slides_U02_S02.3.pptx has the click-by-click build.</a:t>
             </a:r>
           </a:p>
         </p:txBody>
@@ -970,12 +975,17 @@
           <a:lstStyle/>
           <a:p>
             <a:r>
-              <a:t>Shorthand build for germanium (Z = 32), on text boxes, one per segment. The CLICK BUILD line at the end says exactly what each click does. Teach it in this order: write the longhand first; find the noble gas that comes BEFORE germanium and highlight those electrons; put that noble gas in brackets; finish the line. Longhand: 1s^2 2s^2 2p^6 3s^2 3p^6 4s^2 3d^10 4p^2, 2+2+6+2+6+2+10+2 = 32. The first five segments total 18 and are exactly argon's configuration, so [Ar] is a placeholder, a substitution like writing one symbol for a long repeated expression in math. Shorthand: [Ar] 4s^2 3d^10 4p^2, 18 + 2 + 10 + 2 = 32, with 2 unpaired electrons (the two 4p singles). Common error (brief): using the noble gas of the element's own period. Krypton ends germanium's period and comes AFTER it (Z = 36 &gt; 32), so [Kr] would claim 36 electrons; the next slide shows the table strip. [Ar] sits against the remaining segments, in the space the highlighted block occupied, so the line reads [Ar] 4s^2 3d^10 4p^2 after click 3; click 4 writes the finished line as the answer to copy. Cl stays on the previous slide as the static example. A static export or print of this slide shows every shape at once (the highlight, the replaced segments and [Ar] overlap); for a handout use the --preview export of scripts/add_click_builds.py.</a:t>
-            </a:r>
-          </a:p>
-          <a:p>
-            <a:r>
-              <a:t>STATIC FINAL STATE: print and handout copy, no animation. This slide shows the final state of the click build (Ge); the animated deck shows it one click at a time.</a:t>
+              <a:t>Shorthand for germanium (Z = 32). Teach it in this order: write the longhand first; find the noble gas that comes BEFORE germanium and mark those electrons; put that noble gas in brackets; finish the line. Longhand: 1s^2 2s^2 2p^6 3s^2 3p^6 4s^2 3d^10 4p^2, 2+2+6+2+6+2+10+2 = 32. The first five segments total 18 and are exactly argon's configuration, so [Ar] is a placeholder, a substitution like writing one symbol for a long repeated expression in math. Shorthand: [Ar] 4s^2 3d^10 4p^2, 18 + 2 + 10 + 2 = 32, with 2 unpaired electrons (the two 4p singles). Common error (brief): using the noble gas of the element's own period. Krypton ends germanium's period and comes AFTER it (Z = 36 &gt; 32), so [Kr] would claim 36 electrons; the next slide shows the table strip. This slide shows the longhand line, the shorthand line under it, and the check sum. Cl stays on the previous slide as the static example.</a:t>
+            </a:r>
+          </a:p>
+          <a:p>
+            <a:r>
+              <a:t>STATIC FINAL STATE: print and handout copy, no animation. This slide shows the final state of the build (Ge).</a:t>
+            </a:r>
+          </a:p>
+          <a:p>
+            <a:r>
+              <a:t>Animated version: SHULL_CHEM_Slides_U02_S02.3.pptx has the click-by-click build.</a:t>
             </a:r>
           </a:p>
         </p:txBody>
@@ -1242,7 +1252,12 @@
           </a:p>
           <a:p>
             <a:r>
-              <a:t>STATIC FINAL STATE: print and handout copy, no animation. This slide shows the final state of the click build; the animated deck shows it one click at a time.</a:t>
+              <a:t>STATIC FINAL STATE: print and handout copy, no animation. This slide shows the final state of the build.</a:t>
+            </a:r>
+          </a:p>
+          <a:p>
+            <a:r>
+              <a:t>Animated version: SHULL_CHEM_Slides_U02_S02.3.pptx has the click-by-click build.</a:t>
             </a:r>
           </a:p>
         </p:txBody>
@@ -1328,12 +1343,17 @@
           <a:lstStyle/>
           <a:p>
             <a:r>
-              <a:t>Copper click build (the CLICK BUILD line at the end gives the clicks). Boxes for 4s and 3d only; the [Ar] core (18 electrons) is not drawn. Click 1: the atom as the rules predict, [Ar] 4s^2 3d^9 (4s before 3d; 18 + 2 + 9 = 29). Click 2: one 4s arrow leaves. Click 3: a 3d down arrow arrives in the fifth box. End: [Ar] 4s^1 3d^10, 18 + 1 + 10 = 29, one unpaired electron (the 4s). Same electron count before and after: an electron MOVES, none is gained. Say 'measured ground state', not 'textbook error'. The arrows are bookkeeping for the end state; the diagram does not track one electron's journey. Forward pointer to S2.4: the 4s^1 electron leaves first, so Cu^+ = [Ar] 3d^10 and Cu^2+ = [Ar] 3d^9 (both checked by the figure script). The reason follows on the Why slide. Do not extend this to Ag or Au: not taught, not checked (look it up).</a:t>
-            </a:r>
-          </a:p>
-          <a:p>
-            <a:r>
-              <a:t>STATIC FINAL STATE: print and handout copy, no animation. This slide shows the final state of the click build (Cu); the animated deck shows it one click at a time.</a:t>
+              <a:t>Copper. Boxes for 4s and 3d only; the [Ar] core (18 electrons) is not drawn. The atom as the rules predict: [Ar] 4s^2 3d^9 (4s before 3d; 18 + 2 + 9 = 29). The measured ground state: [Ar] 4s^1 3d^10, 18 + 1 + 10 = 29, one unpaired electron (the 4s). Same electron count before and after: an electron MOVES from 4s to 3d, none is gained. Say 'measured ground state', not 'textbook error'. The arrows are bookkeeping for the end state; the diagram does not track one electron's journey. Forward pointer to S2.4: the 4s^1 electron leaves first, so Cu^+ = [Ar] 3d^10 and Cu^2+ = [Ar] 3d^9 (both checked by the figure script). The reason follows on the Why slide. Do not extend this to Ag or Au: not taught, not checked (look it up).</a:t>
+            </a:r>
+          </a:p>
+          <a:p>
+            <a:r>
+              <a:t>STATIC FINAL STATE: print and handout copy, no animation. This slide shows the final state of the build (Cu).</a:t>
+            </a:r>
+          </a:p>
+          <a:p>
+            <a:r>
+              <a:t>Animated version: SHULL_CHEM_Slides_U02_S02.3.pptx has the click-by-click build.</a:t>
             </a:r>
           </a:p>
         </p:txBody>
@@ -1419,12 +1439,17 @@
           <a:lstStyle/>
           <a:p>
             <a:r>
-              <a:t>Chromium click build. Click 1: predicted [Ar] 4s^2 3d^4 (18 + 2 + 4 = 24): four up arrows in 3d and one empty box. Click 2: one 4s arrow leaves. Click 3: an up arrow arrives in the fifth 3d box. End: [Ar] 4s^1 3d^5, 18 + 1 + 5 = 24; every box in 4s and 3d holds exactly one up arrow, all spins parallel (Hund), so 6 unpaired electrons, more than iron's 4. The arrows are bookkeeping for the end state: the arrow that leaves 4s is the down one and the arrow that arrives in 3d is an up one, so do not present it as one electron keeping its spin; the point is the final arrangement. Answer to the unpaired question: 6. Same teaching label as Cu: measured ground state. Mo (same group, one period down) is an exception too, and W is not; not taught, not checked here.</a:t>
-            </a:r>
-          </a:p>
-          <a:p>
-            <a:r>
-              <a:t>STATIC FINAL STATE: print and handout copy, no animation. This slide shows the final state of the click build (Cr); the animated deck shows it one click at a time.</a:t>
+              <a:t>Chromium. The atom as the rules predict: [Ar] 4s^2 3d^4 (18 + 2 + 4 = 24): four up arrows in 3d and one empty box. The measured ground state: [Ar] 4s^1 3d^5, 18 + 1 + 5 = 24; every box in 4s and 3d holds exactly one up arrow, all spins parallel (Hund), so 6 unpaired electrons, more than iron's 4. The arrows are bookkeeping for the end state: the arrow that leaves 4s is the down one and the arrow that arrives in 3d is an up one, so do not present it as one electron keeping its spin; the point is the final arrangement. Answer to the unpaired question: 6. Same teaching label as Cu: measured ground state. Mo (same group, one period down) is an exception too, and W is not; not taught, not checked here.</a:t>
+            </a:r>
+          </a:p>
+          <a:p>
+            <a:r>
+              <a:t>STATIC FINAL STATE: print and handout copy, no animation. This slide shows the final state of the build (Cr).</a:t>
+            </a:r>
+          </a:p>
+          <a:p>
+            <a:r>
+              <a:t>Animated version: SHULL_CHEM_Slides_U02_S02.3.pptx has the click-by-click build.</a:t>
             </a:r>
           </a:p>
         </p:txBody>
@@ -2659,7 +2684,12 @@
           </a:p>
           <a:p>
             <a:r>
-              <a:t>STATIC FINAL STATE: print and handout copy, no animation. This slide shows the final state of the click build; the animated deck shows it one click at a time.</a:t>
+              <a:t>STATIC FINAL STATE: print and handout copy, no animation. This slide shows the final state of the build.</a:t>
+            </a:r>
+          </a:p>
+          <a:p>
+            <a:r>
+              <a:t>Animated version: SHULL_CHEM_Slides_U02_S02.3.pptx has the click-by-click build.</a:t>
             </a:r>
           </a:p>
         </p:txBody>
@@ -2745,12 +2775,17 @@
           <a:lstStyle/>
           <a:p>
             <a:r>
-              <a:t>Click build (see scripts/add_click_builds.py): the three 2p boxes fly in, then one arrow per click: up, up, up (Hund: singles first), then down in box 1 (Pauli: a pair has opposite spins). Result: 2p^4 with one pair and two singles, so 2 unpaired electrons. Have students draw each arrow in their notes at the same click. Same filling as the oxygen example later in this deck.</a:t>
-            </a:r>
-          </a:p>
-          <a:p>
-            <a:r>
-              <a:t>STATIC FINAL STATE: print and handout copy, no animation. This slide shows the final state of the click build; the animated deck shows it one click at a time.</a:t>
+              <a:t>The three 2p boxes hold the oxygen filling: one up arrow in each box first (Hund: singles first), then a down arrow in box 1 (Pauli: a pair has opposite spins). Result: 2p^4 with one pair and two singles, so 2 unpaired electrons. Have students draw the arrows in their notes in that order. Same filling as the oxygen example later in this deck.</a:t>
+            </a:r>
+          </a:p>
+          <a:p>
+            <a:r>
+              <a:t>STATIC FINAL STATE: print and handout copy, no animation. This slide shows the final state of the build.</a:t>
+            </a:r>
+          </a:p>
+          <a:p>
+            <a:r>
+              <a:t>Animated version: SHULL_CHEM_Slides_U02_S02.3.pptx has the click-by-click build.</a:t>
             </a:r>
           </a:p>
         </p:txBody>

</xml_diff>